<commit_message>
feat: auf du umgestellt
</commit_message>
<xml_diff>
--- a/reli-kirche-und-staat/praesentation/Kirche-und-Staat-Beamer.pptx
+++ b/reli-kirche-und-staat/praesentation/Kirche-und-Staat-Beamer.pptx
@@ -631,7 +631,7 @@
           <a:lstStyle/>
           <a:p>
             <a:r>
-              <a:t>Nach zwei Begründungen fragen: „Wer hat ein Argument gehört, das ihn ins Wanken bringt? Wechseln Sie die Ecke — das ist ausdrücklich erlaubt.“</a:t>
+              <a:t>Nach zwei Begründungen fragen: „Wer hat ein Argument gehört, das ihn ins Wanken bringt? Wechselt die Ecke — das ist ausdrücklich erlaubt.“</a:t>
             </a:r>
           </a:p>
         </p:txBody>
@@ -701,7 +701,7 @@
           <a:lstStyle/>
           <a:p>
             <a:r>
-              <a:t>Nach zwei Begründungen fragen: „Wer hat ein Argument gehört, das ihn ins Wanken bringt? Wechseln Sie die Ecke — das ist ausdrücklich erlaubt.“</a:t>
+              <a:t>Nach zwei Begründungen fragen: „Wer hat ein Argument gehört, das ihn ins Wanken bringt? Wechselt die Ecke — das ist ausdrücklich erlaubt.“</a:t>
             </a:r>
           </a:p>
         </p:txBody>
@@ -771,7 +771,7 @@
           <a:lstStyle/>
           <a:p>
             <a:r>
-              <a:t>Nach zwei Begründungen fragen: „Wer hat ein Argument gehört, das ihn ins Wanken bringt? Wechseln Sie die Ecke — das ist ausdrücklich erlaubt.“</a:t>
+              <a:t>Nach zwei Begründungen fragen: „Wer hat ein Argument gehört, das ihn ins Wanken bringt? Wechselt die Ecke — das ist ausdrücklich erlaubt.“</a:t>
             </a:r>
           </a:p>
           <a:p/>
@@ -853,7 +853,7 @@
           <a:p/>
           <a:p>
             <a:r>
-              <a:t>ÜBERLEITUNG: „Damals war die Nähe zwischen Kirche und Staat so eng wie nie — und für manche Menschen wurde sie lebensgefährlich. Nächste Stunde fangen wir genau hier an. Und die Frage, die Sie mitnehmen, ist nicht ‚Wie konnten die nur?‘, sondern: ‚Was hätte ich in diesem Raum gemacht?‘“</a:t>
+              <a:t>ÜBERLEITUNG: „Damals war die Nähe zwischen Kirche und Staat so eng wie nie — und für manche Menschen wurde sie lebensgefährlich. Nächste Stunde fangen wir genau hier an. Und die Frage, die ihr mitnehmt, ist nicht ‚Wie konnten die nur?‘, sondern: ‚Was hätte ich in diesem Raum gemacht?‘“</a:t>
             </a:r>
           </a:p>
           <a:p/>
@@ -1005,7 +1005,7 @@
           <a:p/>
           <a:p>
             <a:r>
-              <a:t>ÜBERLEITUNG: „Die meisten Ihrer Fragen laufen auf dasselbe hinaus: Wie konnten die nur? Ich möchte Ihnen diese Frage wegnehmen. Sie ist bequem — sie stellt uns auf die richtige Seite, bevor wir irgendetwas verstanden haben. Die schwierigere Frage lautet: Was war daran so überzeugend?“</a:t>
+              <a:t>ÜBERLEITUNG: „Die meisten eurer Fragen laufen auf dasselbe hinaus: Wie konnten die nur? Ich möchte euch diese Frage wegnehmen. Sie ist bequem — sie stellt uns auf die richtige Seite, bevor wir irgendetwas verstanden haben. Die schwierigere Frage lautet: Was war daran so überzeugend?“</a:t>
             </a:r>
           </a:p>
         </p:txBody>
@@ -1145,7 +1145,7 @@
           <a:lstStyle/>
           <a:p>
             <a:r>
-              <a:t>Vor dem Austeilen ansagen: „Zwei dieser Texte sind judenfeindlich. Ich gebe sie Ihnen, weil man nicht verstehen kann, was passiert ist, ohne zu sehen, wie normal diese Sätze damals klangen. Wenn Ihnen ein Satz zu nahe geht, sagen Sie es mir.“</a:t>
+              <a:t>Vor dem Austeilen ansagen: „Zwei dieser Texte sind judenfeindlich. Ich gebe sie euch, weil man nicht verstehen kann, was passiert ist, ohne zu sehen, wie normal diese Sätze damals klangen. Wenn euch ein Satz zu nahe geht, sagt es mir.“</a:t>
             </a:r>
           </a:p>
         </p:txBody>
@@ -1285,7 +1285,7 @@
           <a:lstStyle/>
           <a:p>
             <a:r>
-              <a:t>ÜBERLEITUNG: „Das EINE Wort. Nicht: eines von mehreren. Überlegen Sie bis nächste Woche, wem dieser Satz wehtut. Denn dreizehn Tage später haben acht evangelische Theologen — sechs davon aus Franken — eine Gegenschrift veröffentlicht. Nächste Stunde lassen wir die beiden Seiten aufeinandertreffen. Und Sie sitzen nicht im Publikum. Sie sind die beiden Seiten.“</a:t>
+              <a:t>ÜBERLEITUNG: „Das EINE Wort. Nicht: eines von mehreren. Überlegt bis nächste Woche, wem dieser Satz wehtut. Denn dreizehn Tage später haben acht evangelische Theologen — sechs davon aus Franken — eine Gegenschrift veröffentlicht. Nächste Stunde lassen wir die beiden Seiten aufeinandertreffen. Und ihr sitzt nicht im Publikum. Ihr seid die beiden Seiten.“</a:t>
             </a:r>
           </a:p>
         </p:txBody>
@@ -1577,7 +1577,7 @@
           <a:lstStyle/>
           <a:p>
             <a:r>
-              <a:t>ÜBERLEITUNG: „Der Originaltext ist sperrig — Theologendeutsch von 1934. Ihre Aufgabe ist, ihn so zu übersetzen, dass ihn eine Siebtklässlerin versteht. Das ist die härteste Prüfung für Verstehen, die ich kenne: Wer etwas nicht einfach sagen kann, hat es nicht verstanden.“</a:t>
+              <a:t>ÜBERLEITUNG: „Der Originaltext ist sperrig — Theologendeutsch von 1934. Eure Aufgabe ist, ihn so zu übersetzen, dass ihn eine Siebtklässlerin versteht. Das ist die härteste Prüfung für Verstehen, die ich kenne: Wer etwas nicht einfach sagen kann, hat es nicht verstanden.“</a:t>
             </a:r>
           </a:p>
           <a:p/>
@@ -1805,7 +1805,7 @@
           <a:lstStyle/>
           <a:p>
             <a:r>
-              <a:t>ÜBERLEITUNG: „Behalten Sie diesen Zettel. Der Mann, der den Text geschrieben hat, war 1924 stolzer Nationalist und U-Boot-Kommandant. Später saß er sieben Jahre in Sachsenhausen und Dachau. Menschen sind nicht von Anfang an Helden oder Feiglinge — sie werden es, Entscheidung für Entscheidung.“</a:t>
+              <a:t>ÜBERLEITUNG: „Behaltet diesen Zettel. Der Mann, der den Text geschrieben hat, war 1924 stolzer Nationalist und U-Boot-Kommandant. Später saß er sieben Jahre in Sachsenhausen und Dachau. Menschen sind nicht von Anfang an Helden oder Feiglinge — sie werden es, Entscheidung für Entscheidung.“</a:t>
             </a:r>
           </a:p>
         </p:txBody>
@@ -1875,7 +1875,7 @@
           <a:lstStyle/>
           <a:p>
             <a:r>
-              <a:t>ÜBERLEITUNG: „Ich habe eine Leine gespannt. Links: Anpassung. Rechts: Widerstand. Dazwischen ist nichts — kein Raster, keine Markierungen. Den Zwischenraum füllen Sie. Und ich verspreche Ihnen: Sobald die dritte Karte hängt, wird jemand widersprechen wollen.“</a:t>
+              <a:t>ÜBERLEITUNG: „Ich habe eine Leine gespannt. Links: Anpassung. Rechts: Widerstand. Dazwischen ist nichts — kein Raster, keine Markierungen. Den Zwischenraum füllt ihr. Und ich verspreche euch: Sobald die dritte Karte hängt, wird jemand widersprechen wollen.“</a:t>
             </a:r>
           </a:p>
         </p:txBody>
@@ -2027,7 +2027,7 @@
           <a:p/>
           <a:p>
             <a:r>
-              <a:t>Erst beim Hinausgehen, im Vorbeigehen: „Nächste Woche springen wir vierzig Jahre weiter. Gleiches Land, andere Diktatur — und diesmal bringen Sie Ihre Handys mit.“</a:t>
+              <a:t>Erst beim Hinausgehen, im Vorbeigehen: „Nächste Woche springen wir vierzig Jahre weiter. Gleiches Land, andere Diktatur — und diesmal bringt ihr eure Handys mit.“</a:t>
             </a:r>
           </a:p>
         </p:txBody>
@@ -2313,7 +2313,7 @@
           <a:lstStyle/>
           <a:p>
             <a:r>
-              <a:t>Regel laut ansagen: „Zu jeder Behauptung auf Ihrer Tafel muss ich fragen dürfen: Wo steht das? — und Sie müssen es mir zeigen können.“ Startquellen: LeMO (dhm.de/lemo) und Bundesstiftung Aufarbeitung.</a:t>
+              <a:t>Regel laut ansagen: „Zu jeder Behauptung auf eurer Tafel muss ich fragen dürfen: Wo steht das? — und ihr müsst es mir zeigen können.“ Startquellen: LeMO (dhm.de/lemo) und Bundesstiftung Aufarbeitung.</a:t>
             </a:r>
           </a:p>
         </p:txBody>
@@ -2459,7 +2459,7 @@
           <a:p/>
           <a:p>
             <a:r>
-              <a:t>ÜBERLEITUNG: „Nächste Woche steht kein Jahr mehr an der Tafel, sondern dieses. Und Sie werden etwas tun, das seit 1934 kaum jemand mehr gemacht hat: Sie schreiben eigene Bekenntnissätze. Und die hängen wir an die Tür.“</a:t>
+              <a:t>ÜBERLEITUNG: „Nächste Woche steht kein Jahr mehr an der Tafel, sondern dieses. Und ihr werdet etwas tun, das seit 1934 kaum jemand mehr gemacht hat: Ihr schreibt eigene Bekenntnissätze. Und die hängen wir an die Tür.“</a:t>
             </a:r>
           </a:p>
         </p:txBody>
@@ -2611,7 +2611,7 @@
           <a:p/>
           <a:p>
             <a:r>
-              <a:t>ÜBERLEITUNG: „Ich werde Ihnen nicht sagen, was Sie wählen sollen — das steht mir nicht zu und wäre auch verboten. Wir schauen uns an, was die Kirchen sagen, warum sie es sagen, und ob sie es sagen dürfen.“</a:t>
+              <a:t>ÜBERLEITUNG: „Ich werde euch nicht sagen, was ihr wählen sollt — das steht mir nicht zu und wäre auch verboten. Wir schauen uns an, was die Kirchen sagen, warum sie es sagen, und ob sie es sagen dürfen.“</a:t>
             </a:r>
           </a:p>
         </p:txBody>
@@ -2827,7 +2827,7 @@
           <a:lstStyle/>
           <a:p>
             <a:r>
-              <a:t>ÜBERLEITUNG: „Sie haben in der dritten Doppelstunde einen Satzanfang übersetzt, den ich Ihnen jetzt zurückgebe: ‚Wir verwerfen die falsche Lehre, als ob …‘ 1934 haben acht Sätze in dieser Form eine Kirche verändert. Sie sind jetzt dran. Nicht als Übung, sondern im Ernst. Und weil das eine hohe Messlatte ist, gibt es eine Bedingung: Jede These muss sich an einer Bibelstelle festmachen lassen. Sonst ist es Meinung.“</a:t>
+              <a:t>ÜBERLEITUNG: „Ihr habt in der dritten Doppelstunde einen Satzanfang übersetzt, den ich euch jetzt zurückgebe: ‚Wir verwerfen die falsche Lehre, als ob …‘ 1934 haben acht Sätze in dieser Form eine Kirche verändert. Ihr seid jetzt dran. Nicht als Übung, sondern im Ernst. Und weil das eine hohe Messlatte ist, gibt es eine Bedingung: Jede These muss sich an einer Bibelstelle festmachen lassen. Sonst ist es Meinung.“</a:t>
             </a:r>
           </a:p>
         </p:txBody>
@@ -3183,7 +3183,7 @@
           <a:lstStyle/>
           <a:p>
             <a:r>
-              <a:t>Zwei bis drei Beispiele sammeln und neben die Thesen an die Tür hängen — mit der Überschrift, die Sie dazuschreiben: „Und das machen wir daraus.“</a:t>
+              <a:t>Zwei bis drei Beispiele sammeln und neben die Thesen an die Tür hängen — mit der Überschrift, die du dazuschreibst: „Und das machen wir daraus.“</a:t>
             </a:r>
           </a:p>
         </p:txBody>
@@ -3259,13 +3259,13 @@
           <a:p/>
           <a:p>
             <a:r>
-              <a:t>WORTLAUT: „Das haben Sie vor drei Wochen aufgeschrieben. Es war Ihre Antwort auf die Frage, was Menschen 1934 geholfen hat zu widersprechen. Lesen Sie es noch einmal — und lesen Sie es diesmal nicht als Geschichte, sondern als Gebrauchsanweisung.“</a:t>
+              <a:t>WORTLAUT: „Das habt ihr vor drei Wochen aufgeschrieben. Es war eure Antwort auf die Frage, was Menschen 1934 geholfen hat zu widersprechen. Lest es noch einmal — und lest es diesmal nicht als Geschichte, sondern als Gebrauchsanweisung.“</a:t>
             </a:r>
           </a:p>
           <a:p/>
           <a:p>
             <a:r>
-              <a:t>„Und zum Schluss: Kleben Sie noch einmal auf das Plakat von heute Morgen. Dieselbe Frage, zweiter Klebepunkt, andere Farbe. Ich sage Ihnen nicht, wo Sie kleben sollen. Ich möchte nur, dass Sie sehen, ob dieser Vormittag etwas verschoben hat.“</a:t>
+              <a:t>„Und zum Schluss: Klebt noch einmal auf das Plakat von heute Morgen. Dieselbe Frage, zweiter Klebepunkt, andere Farbe. Ich sage euch nicht, wo ihr kleben sollt. Ich möchte nur, dass ihr seht, ob dieser Vormittag etwas verschoben hat.“</a:t>
             </a:r>
           </a:p>
         </p:txBody>
@@ -3335,7 +3335,7 @@
           <a:lstStyle/>
           <a:p>
             <a:r>
-              <a:t>ÜBERLEITUNG: „Ich höre viermal dasselbe Wort: Kirche. Sie haben recht — in jedem dieser Bilder steckt Kirche. Aber schauen Sie genau hin: In keinem einzigen ist eine Kirche zu sehen. Das hier ist eine Lohnabrechnung, das ein Rettungswagen, das ein Stundenplan. Das sind lauter staatliche Angelegenheiten. Und trotzdem ist Kirche darin. Wie kommt sie da hinein?“</a:t>
+              <a:t>ÜBERLEITUNG: „Ich höre viermal dasselbe Wort: Kirche. Ihr habt recht — in jedem dieser Bilder steckt Kirche. Aber schaut genau hin: In keinem einzigen ist eine Kirche zu sehen. Das hier ist eine Lohnabrechnung, das ein Rettungswagen, das ein Stundenplan. Das sind lauter staatliche Angelegenheiten. Und trotzdem ist Kirche darin. Wie kommt sie da hinein?“</a:t>
             </a:r>
           </a:p>
         </p:txBody>
@@ -3481,7 +3481,7 @@
           <a:p/>
           <a:p>
             <a:r>
-              <a:t>ÜBERLEITUNG: „Diese Frage kann ich Ihnen nicht beantworten, ohne dass Sie wissen, worüber wir reden. Also machen wir es umgekehrt: Sie recherchieren selbst. Jede Gruppe wird für zwanzig Minuten die einzige Person im Raum, die sich mit ihrem Thema auskennt.“</a:t>
+              <a:t>ÜBERLEITUNG: „Diese Frage kann ich euch nicht beantworten, ohne dass ihr wisst, worüber wir reden. Also machen wir es umgekehrt: Ihr recherchiert selbst. Jede Gruppe wird für zwanzig Minuten die einzige Person im Raum, die sich mit ihrem Thema auskennt.“</a:t>
             </a:r>
           </a:p>
         </p:txBody>
@@ -3551,7 +3551,7 @@
           <a:lstStyle/>
           <a:p>
             <a:r>
-              <a:t>ÜBERLEITUNG danach: „Zeit ist um. Ab jetzt gilt: Ihr Blatt bleibt liegen, Sie nehmen nur Ihren Kopf mit. Wenn Ihre Zuhörer am Ende Ihr Feld ‚Streitpunkt‘ nicht ausfüllen können, haben Sie schlecht erklärt — nicht die anderen schlecht zugehört.“</a:t>
+              <a:t>ÜBERLEITUNG danach: „Zeit ist um. Ab jetzt gilt: Euer Blatt bleibt liegen, ihr nehmt nur euren Kopf mit. Wenn eure Zuhörer am Ende euer Feld ‚Streitpunkt‘ nicht ausfüllen können, habt ihr schlecht erklärt — nicht die anderen schlecht zugehört.“</a:t>
             </a:r>
           </a:p>
         </p:txBody>
@@ -3621,7 +3621,7 @@
           <a:lstStyle/>
           <a:p>
             <a:r>
-              <a:t>Nach zwei Begründungen fragen: „Wer hat ein Argument gehört, das ihn ins Wanken bringt? Wechseln Sie die Ecke — das ist ausdrücklich erlaubt.“</a:t>
+              <a:t>Nach zwei Begründungen fragen: „Wer hat ein Argument gehört, das ihn ins Wanken bringt? Wechselt die Ecke — das ist ausdrücklich erlaubt.“</a:t>
             </a:r>
           </a:p>
         </p:txBody>
@@ -8037,7 +8037,7 @@
                 </a:solidFill>
                 <a:latin typeface="Consolas"/>
               </a:rPr>
-              <a:t>Stellen Sie sich in die Ecke, die zu Ihrer Meinung passt.</a:t>
+              <a:t>Stellt euch in die Ecke, die zu eurer Meinung passt.</a:t>
             </a:r>
           </a:p>
         </p:txBody>
@@ -8180,7 +8180,7 @@
                 </a:solidFill>
                 <a:latin typeface="Consolas"/>
               </a:rPr>
-              <a:t>Stellen Sie sich in die Ecke, die zu Ihrer Meinung passt.</a:t>
+              <a:t>Stellt euch in die Ecke, die zu eurer Meinung passt.</a:t>
             </a:r>
           </a:p>
         </p:txBody>
@@ -8323,7 +8323,7 @@
                 </a:solidFill>
                 <a:latin typeface="Consolas"/>
               </a:rPr>
-              <a:t>Stellen Sie sich in die Ecke, die zu Ihrer Meinung passt.</a:t>
+              <a:t>Stellt euch in die Ecke, die zu eurer Meinung passt.</a:t>
             </a:r>
           </a:p>
         </p:txBody>
@@ -8466,7 +8466,7 @@
                 </a:solidFill>
                 <a:latin typeface="Consolas"/>
               </a:rPr>
-              <a:t>Stellen Sie sich in die Ecke, die zu Ihrer Meinung passt.</a:t>
+              <a:t>Stellt euch in die Ecke, die zu eurer Meinung passt.</a:t>
             </a:r>
           </a:p>
         </p:txBody>
@@ -9370,7 +9370,7 @@
                 </a:solidFill>
                 <a:latin typeface="Calibri"/>
               </a:rPr>
-              <a:t>1.  SEHEN — Notieren Sie fünf Dinge, die Sie auf dem Bild tatsächlich sehen. Keine Deutung, nur Gegenstände.</a:t>
+              <a:t>1.  SEHEN — Notiere fünf Dinge, die du auf dem Bild tatsächlich siehst. Keine Deutung, nur Gegenstände.</a:t>
             </a:r>
           </a:p>
           <a:p>
@@ -9386,7 +9386,7 @@
                 </a:solidFill>
                 <a:latin typeface="Calibri"/>
               </a:rPr>
-              <a:t>2.  VERMISSEN — Notieren Sie eine Sache, die Sie in einer Kirche erwarten würden und die hier fehlt oder überdeckt ist.</a:t>
+              <a:t>2.  VERMISSEN — Notiere eine Sache, die du in einer Kirche erwarten würdest und die hier fehlt oder überdeckt ist.</a:t>
             </a:r>
           </a:p>
           <a:p>
@@ -9402,7 +9402,7 @@
                 </a:solidFill>
                 <a:latin typeface="Calibri"/>
               </a:rPr>
-              <a:t>3.  FRAGEN — Formulieren Sie die eine Frage, die Sie den Menschen auf diesem Bild stellen würden.</a:t>
+              <a:t>3.  FRAGEN — Formuliere die eine Frage, die du den Menschen auf diesem Bild stellen würdest.</a:t>
             </a:r>
           </a:p>
         </p:txBody>
@@ -13723,7 +13723,7 @@
                 </a:solidFill>
                 <a:latin typeface="Consolas"/>
               </a:rPr>
-              <a:t>Ein Satz. Wird nicht eingesammelt und nicht vorgelesen. Der Zettel gehört Ihnen.</a:t>
+              <a:t>Ein Satz. Wird nicht eingesammelt und nicht vorgelesen. Der Zettel gehört dir.</a:t>
             </a:r>
           </a:p>
         </p:txBody>
@@ -17096,7 +17096,7 @@
                 </a:solidFill>
                 <a:latin typeface="Georgia"/>
               </a:rPr>
-              <a:t>Sie gehen schweigend durch die Ausstellung — wie in einem echten Museum.</a:t>
+              <a:t>Ihr geht schweigend durch die Ausstellung — wie in einem echten Museum.</a:t>
             </a:r>
           </a:p>
           <a:p>
@@ -17128,7 +17128,7 @@
                 </a:solidFill>
                 <a:latin typeface="Georgia"/>
               </a:rPr>
-              <a:t>Drei Klebepunkte, und die kommen auf die offenen Fragen, die Sie am meisten beschäftigen.</a:t>
+              <a:t>Drei Klebepunkte, und die kommen auf die offenen Fragen, die euch am meisten beschäftigen.</a:t>
             </a:r>
           </a:p>
           <a:p>
@@ -18058,7 +18058,7 @@
                 </a:solidFill>
                 <a:latin typeface="Consolas"/>
               </a:rPr>
-              <a:t>Kleben Sie einen Punkt auf die Linie — bevor wir anfangen.</a:t>
+              <a:t>Klebt einen Punkt auf die Linie — bevor wir anfangen.</a:t>
             </a:r>
           </a:p>
         </p:txBody>
@@ -18991,7 +18991,7 @@
                 </a:solidFill>
                 <a:latin typeface="Georgia"/>
               </a:rPr>
-              <a:t>Genau das war 1933 die Mehrheitsmeinung in dieser Kirche. Römer 13, Sie erinnern sich.</a:t>
+              <a:t>Genau das war 1933 die Mehrheitsmeinung in dieser Kirche. Römer 13, ihr erinnert euch.</a:t>
             </a:r>
           </a:p>
           <a:p>
@@ -19055,7 +19055,7 @@
                 </a:solidFill>
                 <a:latin typeface="Georgia"/>
               </a:rPr>
-              <a:t>Wo verläuft die Ihrer Meinung nach?</a:t>
+              <a:t>Wo verläuft die eurer Meinung nach?</a:t>
             </a:r>
           </a:p>
         </p:txBody>
@@ -20748,7 +20748,7 @@
                 </a:solidFill>
                 <a:latin typeface="Georgia"/>
               </a:rPr>
-              <a:t>Genau das haben Sie heute getan.</a:t>
+              <a:t>Genau das habt ihr heute getan.</a:t>
             </a:r>
           </a:p>
         </p:txBody>
@@ -20787,7 +20787,7 @@
                 </a:solidFill>
                 <a:latin typeface="Consolas"/>
               </a:rPr>
-              <a:t>Ihre eigene Antwort aus Doppelstunde 4 — vor drei Wochen aufgeschrieben</a:t>
+              <a:t>Eure eigene Antwort aus Doppelstunde 4 — vor drei Wochen aufgeschrieben</a:t>
             </a:r>
           </a:p>
         </p:txBody>

</xml_diff>